<commit_message>
rebuilt site and added links
</commit_message>
<xml_diff>
--- a/public/images/img_batteries/Sketches.pptx
+++ b/public/images/img_batteries/Sketches.pptx
@@ -117,7 +117,7 @@
 <file path=ppt/revisionInfo.xml><?xml version="1.0" encoding="utf-8"?>
 <p1510:revInfo xmlns:a="http://schemas.openxmlformats.org/drawingml/2006/main" xmlns:r="http://schemas.openxmlformats.org/officeDocument/2006/relationships" xmlns:p1510="http://schemas.microsoft.com/office/powerpoint/2015/10/main">
   <p1510:revLst>
-    <p1510:client id="{E9DF4F5E-E9CF-4228-8ACD-5373012E048E}" v="162" dt="2025-08-11T23:35:34.368"/>
+    <p1510:client id="{55359D5A-C2D6-43F6-8842-3C147A0DF20D}" v="35" dt="2026-04-23T00:12:17.532"/>
   </p1510:revLst>
 </p1510:revInfo>
 </file>
@@ -125,282 +125,20 @@
 <file path=ppt/changesInfos/changesInfo1.xml><?xml version="1.0" encoding="utf-8"?>
 <pc:chgInfo xmlns:a="http://schemas.openxmlformats.org/drawingml/2006/main" xmlns:r="http://schemas.openxmlformats.org/officeDocument/2006/relationships" xmlns:ac="http://schemas.microsoft.com/office/drawing/2013/main/command" xmlns:pc="http://schemas.microsoft.com/office/powerpoint/2013/main/command">
   <pc:docChgLst>
-    <pc:chgData name="Julien Otis-Laperrière" userId="f155e897-dc35-4228-8a21-1627442ea9bf" providerId="ADAL" clId="{E9DF4F5E-E9CF-4228-8ACD-5373012E048E}"/>
-    <pc:docChg chg="undo redo custSel addSld modSld">
-      <pc:chgData name="Julien Otis-Laperrière" userId="f155e897-dc35-4228-8a21-1627442ea9bf" providerId="ADAL" clId="{E9DF4F5E-E9CF-4228-8ACD-5373012E048E}" dt="2025-08-12T15:55:03.383" v="3351" actId="20577"/>
+    <pc:chgData name="Julien Otis-Laperrière" userId="f155e897-dc35-4228-8a21-1627442ea9bf" providerId="ADAL" clId="{62CFAC18-12DD-4069-AF2D-D3D5F30C1BC4}"/>
+    <pc:docChg chg="undo redo custSel modSld">
+      <pc:chgData name="Julien Otis-Laperrière" userId="f155e897-dc35-4228-8a21-1627442ea9bf" providerId="ADAL" clId="{62CFAC18-12DD-4069-AF2D-D3D5F30C1BC4}" dt="2026-04-23T00:12:17.517" v="117" actId="5736"/>
       <pc:docMkLst>
         <pc:docMk/>
       </pc:docMkLst>
-      <pc:sldChg chg="addSp delSp modSp mod">
-        <pc:chgData name="Julien Otis-Laperrière" userId="f155e897-dc35-4228-8a21-1627442ea9bf" providerId="ADAL" clId="{E9DF4F5E-E9CF-4228-8ACD-5373012E048E}" dt="2025-08-11T15:43:02.149" v="940" actId="20577"/>
-        <pc:sldMkLst>
-          <pc:docMk/>
-          <pc:sldMk cId="4174478034" sldId="256"/>
-        </pc:sldMkLst>
-        <pc:spChg chg="del">
-          <ac:chgData name="Julien Otis-Laperrière" userId="f155e897-dc35-4228-8a21-1627442ea9bf" providerId="ADAL" clId="{E9DF4F5E-E9CF-4228-8ACD-5373012E048E}" dt="2025-08-11T15:13:52.674" v="2" actId="478"/>
-          <ac:spMkLst>
-            <pc:docMk/>
-            <pc:sldMk cId="4174478034" sldId="256"/>
-            <ac:spMk id="2" creationId="{CCADF995-BB56-3A14-FBAC-CCAEBBC4B1A1}"/>
-          </ac:spMkLst>
-        </pc:spChg>
-        <pc:spChg chg="del">
-          <ac:chgData name="Julien Otis-Laperrière" userId="f155e897-dc35-4228-8a21-1627442ea9bf" providerId="ADAL" clId="{E9DF4F5E-E9CF-4228-8ACD-5373012E048E}" dt="2025-08-11T15:13:53.825" v="3" actId="478"/>
-          <ac:spMkLst>
-            <pc:docMk/>
-            <pc:sldMk cId="4174478034" sldId="256"/>
-            <ac:spMk id="3" creationId="{4D1D972F-53CD-A52B-7152-0DCE928F8A86}"/>
-          </ac:spMkLst>
-        </pc:spChg>
-        <pc:spChg chg="add mod">
-          <ac:chgData name="Julien Otis-Laperrière" userId="f155e897-dc35-4228-8a21-1627442ea9bf" providerId="ADAL" clId="{E9DF4F5E-E9CF-4228-8ACD-5373012E048E}" dt="2025-08-11T15:42:00.973" v="897" actId="1076"/>
-          <ac:spMkLst>
-            <pc:docMk/>
-            <pc:sldMk cId="4174478034" sldId="256"/>
-            <ac:spMk id="13" creationId="{3EDA82EC-B79B-6482-F1F8-9C39C69D022D}"/>
-          </ac:spMkLst>
-        </pc:spChg>
-        <pc:spChg chg="add mod">
-          <ac:chgData name="Julien Otis-Laperrière" userId="f155e897-dc35-4228-8a21-1627442ea9bf" providerId="ADAL" clId="{E9DF4F5E-E9CF-4228-8ACD-5373012E048E}" dt="2025-08-11T15:23:38.423" v="536" actId="1076"/>
-          <ac:spMkLst>
-            <pc:docMk/>
-            <pc:sldMk cId="4174478034" sldId="256"/>
-            <ac:spMk id="16" creationId="{A7720CB7-6F01-7B4A-CF3A-152D61E9AB6E}"/>
-          </ac:spMkLst>
-        </pc:spChg>
-        <pc:spChg chg="add del">
-          <ac:chgData name="Julien Otis-Laperrière" userId="f155e897-dc35-4228-8a21-1627442ea9bf" providerId="ADAL" clId="{E9DF4F5E-E9CF-4228-8ACD-5373012E048E}" dt="2025-08-11T15:32:29.727" v="647" actId="22"/>
-          <ac:spMkLst>
-            <pc:docMk/>
-            <pc:sldMk cId="4174478034" sldId="256"/>
-            <ac:spMk id="21" creationId="{3C3B8FB7-DEC0-EFCE-D6C1-F5F3C3360AF1}"/>
-          </ac:spMkLst>
-        </pc:spChg>
-        <pc:spChg chg="add mod">
-          <ac:chgData name="Julien Otis-Laperrière" userId="f155e897-dc35-4228-8a21-1627442ea9bf" providerId="ADAL" clId="{E9DF4F5E-E9CF-4228-8ACD-5373012E048E}" dt="2025-08-11T15:33:00.254" v="767" actId="404"/>
-          <ac:spMkLst>
-            <pc:docMk/>
-            <pc:sldMk cId="4174478034" sldId="256"/>
-            <ac:spMk id="23" creationId="{3B24559D-6AC7-035C-9E58-AAFDDA0C46E4}"/>
-          </ac:spMkLst>
-        </pc:spChg>
-        <pc:spChg chg="add mod">
-          <ac:chgData name="Julien Otis-Laperrière" userId="f155e897-dc35-4228-8a21-1627442ea9bf" providerId="ADAL" clId="{E9DF4F5E-E9CF-4228-8ACD-5373012E048E}" dt="2025-08-11T15:41:51.905" v="894" actId="1076"/>
-          <ac:spMkLst>
-            <pc:docMk/>
-            <pc:sldMk cId="4174478034" sldId="256"/>
-            <ac:spMk id="24" creationId="{17444BC7-C935-4B98-2F76-DA5B025084BB}"/>
-          </ac:spMkLst>
-        </pc:spChg>
-        <pc:graphicFrameChg chg="add mod modGraphic">
-          <ac:chgData name="Julien Otis-Laperrière" userId="f155e897-dc35-4228-8a21-1627442ea9bf" providerId="ADAL" clId="{E9DF4F5E-E9CF-4228-8ACD-5373012E048E}" dt="2025-08-11T15:43:02.149" v="940" actId="20577"/>
-          <ac:graphicFrameMkLst>
-            <pc:docMk/>
-            <pc:sldMk cId="4174478034" sldId="256"/>
-            <ac:graphicFrameMk id="4" creationId="{9EFA6192-0ACA-3F19-19E7-048AF76CC689}"/>
-          </ac:graphicFrameMkLst>
-        </pc:graphicFrameChg>
-        <pc:cxnChg chg="add del">
-          <ac:chgData name="Julien Otis-Laperrière" userId="f155e897-dc35-4228-8a21-1627442ea9bf" providerId="ADAL" clId="{E9DF4F5E-E9CF-4228-8ACD-5373012E048E}" dt="2025-08-11T15:18:05.892" v="314" actId="11529"/>
-          <ac:cxnSpMkLst>
-            <pc:docMk/>
-            <pc:sldMk cId="4174478034" sldId="256"/>
-            <ac:cxnSpMk id="6" creationId="{0B348E0E-7EEF-DB1F-AB04-501338908C32}"/>
-          </ac:cxnSpMkLst>
-        </pc:cxnChg>
-        <pc:cxnChg chg="add del mod">
-          <ac:chgData name="Julien Otis-Laperrière" userId="f155e897-dc35-4228-8a21-1627442ea9bf" providerId="ADAL" clId="{E9DF4F5E-E9CF-4228-8ACD-5373012E048E}" dt="2025-08-11T15:18:27.119" v="324" actId="11529"/>
-          <ac:cxnSpMkLst>
-            <pc:docMk/>
-            <pc:sldMk cId="4174478034" sldId="256"/>
-            <ac:cxnSpMk id="8" creationId="{4D70E8BC-75FA-6168-EA42-B58762863924}"/>
-          </ac:cxnSpMkLst>
-        </pc:cxnChg>
-        <pc:cxnChg chg="add mod">
-          <ac:chgData name="Julien Otis-Laperrière" userId="f155e897-dc35-4228-8a21-1627442ea9bf" providerId="ADAL" clId="{E9DF4F5E-E9CF-4228-8ACD-5373012E048E}" dt="2025-08-11T15:42:04.781" v="898" actId="14100"/>
-          <ac:cxnSpMkLst>
-            <pc:docMk/>
-            <pc:sldMk cId="4174478034" sldId="256"/>
-            <ac:cxnSpMk id="11" creationId="{A6622EB3-9401-E27E-CF08-D44C52CA13B7}"/>
-          </ac:cxnSpMkLst>
-        </pc:cxnChg>
-        <pc:cxnChg chg="add mod">
-          <ac:chgData name="Julien Otis-Laperrière" userId="f155e897-dc35-4228-8a21-1627442ea9bf" providerId="ADAL" clId="{E9DF4F5E-E9CF-4228-8ACD-5373012E048E}" dt="2025-08-11T15:25:21.391" v="556" actId="14100"/>
-          <ac:cxnSpMkLst>
-            <pc:docMk/>
-            <pc:sldMk cId="4174478034" sldId="256"/>
-            <ac:cxnSpMk id="14" creationId="{B64FA57D-DABE-CA52-198B-E35ACAEFDBAF}"/>
-          </ac:cxnSpMkLst>
-        </pc:cxnChg>
-      </pc:sldChg>
-      <pc:sldChg chg="addSp delSp modSp new mod">
-        <pc:chgData name="Julien Otis-Laperrière" userId="f155e897-dc35-4228-8a21-1627442ea9bf" providerId="ADAL" clId="{E9DF4F5E-E9CF-4228-8ACD-5373012E048E}" dt="2025-08-11T16:17:05.640" v="998" actId="1076"/>
-        <pc:sldMkLst>
-          <pc:docMk/>
-          <pc:sldMk cId="3563616629" sldId="257"/>
-        </pc:sldMkLst>
-        <pc:spChg chg="del">
-          <ac:chgData name="Julien Otis-Laperrière" userId="f155e897-dc35-4228-8a21-1627442ea9bf" providerId="ADAL" clId="{E9DF4F5E-E9CF-4228-8ACD-5373012E048E}" dt="2025-08-11T16:15:39.490" v="962" actId="478"/>
-          <ac:spMkLst>
-            <pc:docMk/>
-            <pc:sldMk cId="3563616629" sldId="257"/>
-            <ac:spMk id="2" creationId="{8955EEAA-F2EC-3CAB-E8D8-45F0F63F126F}"/>
-          </ac:spMkLst>
-        </pc:spChg>
-        <pc:spChg chg="del">
-          <ac:chgData name="Julien Otis-Laperrière" userId="f155e897-dc35-4228-8a21-1627442ea9bf" providerId="ADAL" clId="{E9DF4F5E-E9CF-4228-8ACD-5373012E048E}" dt="2025-08-11T16:15:37.939" v="961" actId="478"/>
-          <ac:spMkLst>
-            <pc:docMk/>
-            <pc:sldMk cId="3563616629" sldId="257"/>
-            <ac:spMk id="3" creationId="{15EB9DAF-E6E0-204F-2C0A-C572EE07BEF4}"/>
-          </ac:spMkLst>
-        </pc:spChg>
-        <pc:spChg chg="add del mod">
-          <ac:chgData name="Julien Otis-Laperrière" userId="f155e897-dc35-4228-8a21-1627442ea9bf" providerId="ADAL" clId="{E9DF4F5E-E9CF-4228-8ACD-5373012E048E}" dt="2025-08-11T16:15:25.047" v="959" actId="478"/>
-          <ac:spMkLst>
-            <pc:docMk/>
-            <pc:sldMk cId="3563616629" sldId="257"/>
-            <ac:spMk id="4" creationId="{7CD8CFBC-4DD9-EDBC-66A1-112E755BC22C}"/>
-          </ac:spMkLst>
-        </pc:spChg>
-        <pc:spChg chg="add mod">
-          <ac:chgData name="Julien Otis-Laperrière" userId="f155e897-dc35-4228-8a21-1627442ea9bf" providerId="ADAL" clId="{E9DF4F5E-E9CF-4228-8ACD-5373012E048E}" dt="2025-08-11T16:15:53.897" v="964" actId="554"/>
-          <ac:spMkLst>
-            <pc:docMk/>
-            <pc:sldMk cId="3563616629" sldId="257"/>
-            <ac:spMk id="6" creationId="{A43F5A3C-CD0C-9454-8366-538615BF3BF4}"/>
-          </ac:spMkLst>
-        </pc:spChg>
-        <pc:spChg chg="add mod">
-          <ac:chgData name="Julien Otis-Laperrière" userId="f155e897-dc35-4228-8a21-1627442ea9bf" providerId="ADAL" clId="{E9DF4F5E-E9CF-4228-8ACD-5373012E048E}" dt="2025-08-11T16:15:53.897" v="964" actId="554"/>
-          <ac:spMkLst>
-            <pc:docMk/>
-            <pc:sldMk cId="3563616629" sldId="257"/>
-            <ac:spMk id="8" creationId="{843F1428-1DE6-3390-3499-2BA07B686F74}"/>
-          </ac:spMkLst>
-        </pc:spChg>
-        <pc:spChg chg="add mod">
-          <ac:chgData name="Julien Otis-Laperrière" userId="f155e897-dc35-4228-8a21-1627442ea9bf" providerId="ADAL" clId="{E9DF4F5E-E9CF-4228-8ACD-5373012E048E}" dt="2025-08-11T16:15:53.897" v="964" actId="554"/>
-          <ac:spMkLst>
-            <pc:docMk/>
-            <pc:sldMk cId="3563616629" sldId="257"/>
-            <ac:spMk id="9" creationId="{DD7ECE7D-B534-3005-504D-85687990845C}"/>
-          </ac:spMkLst>
-        </pc:spChg>
-        <pc:spChg chg="add mod">
-          <ac:chgData name="Julien Otis-Laperrière" userId="f155e897-dc35-4228-8a21-1627442ea9bf" providerId="ADAL" clId="{E9DF4F5E-E9CF-4228-8ACD-5373012E048E}" dt="2025-08-11T16:16:47.906" v="995" actId="20577"/>
-          <ac:spMkLst>
-            <pc:docMk/>
-            <pc:sldMk cId="3563616629" sldId="257"/>
-            <ac:spMk id="10" creationId="{069258F0-253C-B1A9-DDB4-19B84737C1A2}"/>
-          </ac:spMkLst>
-        </pc:spChg>
-        <pc:spChg chg="add mod">
-          <ac:chgData name="Julien Otis-Laperrière" userId="f155e897-dc35-4228-8a21-1627442ea9bf" providerId="ADAL" clId="{E9DF4F5E-E9CF-4228-8ACD-5373012E048E}" dt="2025-08-11T16:16:22.399" v="988" actId="1076"/>
-          <ac:spMkLst>
-            <pc:docMk/>
-            <pc:sldMk cId="3563616629" sldId="257"/>
-            <ac:spMk id="11" creationId="{B1077A52-0F2D-0DB5-888B-4DEB3B2A932C}"/>
-          </ac:spMkLst>
-        </pc:spChg>
-        <pc:spChg chg="add del mod">
-          <ac:chgData name="Julien Otis-Laperrière" userId="f155e897-dc35-4228-8a21-1627442ea9bf" providerId="ADAL" clId="{E9DF4F5E-E9CF-4228-8ACD-5373012E048E}" dt="2025-08-11T16:16:30.391" v="991" actId="478"/>
-          <ac:spMkLst>
-            <pc:docMk/>
-            <pc:sldMk cId="3563616629" sldId="257"/>
-            <ac:spMk id="12" creationId="{B64CB338-BB84-816F-54EF-E324C3D11EE7}"/>
-          </ac:spMkLst>
-        </pc:spChg>
-        <pc:spChg chg="add del mod">
-          <ac:chgData name="Julien Otis-Laperrière" userId="f155e897-dc35-4228-8a21-1627442ea9bf" providerId="ADAL" clId="{E9DF4F5E-E9CF-4228-8ACD-5373012E048E}" dt="2025-08-11T16:16:27.301" v="990" actId="478"/>
-          <ac:spMkLst>
-            <pc:docMk/>
-            <pc:sldMk cId="3563616629" sldId="257"/>
-            <ac:spMk id="13" creationId="{7303D6A4-FA7C-ABFE-D9DB-2F10EBBF216B}"/>
-          </ac:spMkLst>
-        </pc:spChg>
-        <pc:spChg chg="add mod">
-          <ac:chgData name="Julien Otis-Laperrière" userId="f155e897-dc35-4228-8a21-1627442ea9bf" providerId="ADAL" clId="{E9DF4F5E-E9CF-4228-8ACD-5373012E048E}" dt="2025-08-11T16:16:51.028" v="996" actId="20577"/>
-          <ac:spMkLst>
-            <pc:docMk/>
-            <pc:sldMk cId="3563616629" sldId="257"/>
-            <ac:spMk id="14" creationId="{DEC80892-DB02-26BD-B018-782C17FD7D30}"/>
-          </ac:spMkLst>
-        </pc:spChg>
-        <pc:spChg chg="add mod">
-          <ac:chgData name="Julien Otis-Laperrière" userId="f155e897-dc35-4228-8a21-1627442ea9bf" providerId="ADAL" clId="{E9DF4F5E-E9CF-4228-8ACD-5373012E048E}" dt="2025-08-11T16:17:05.640" v="998" actId="1076"/>
-          <ac:spMkLst>
-            <pc:docMk/>
-            <pc:sldMk cId="3563616629" sldId="257"/>
-            <ac:spMk id="15" creationId="{262D463C-98E6-045B-394C-8FA6EA5FA2C4}"/>
-          </ac:spMkLst>
-        </pc:spChg>
-        <pc:cxnChg chg="add mod">
-          <ac:chgData name="Julien Otis-Laperrière" userId="f155e897-dc35-4228-8a21-1627442ea9bf" providerId="ADAL" clId="{E9DF4F5E-E9CF-4228-8ACD-5373012E048E}" dt="2025-08-11T16:15:35.216" v="960"/>
-          <ac:cxnSpMkLst>
-            <pc:docMk/>
-            <pc:sldMk cId="3563616629" sldId="257"/>
-            <ac:cxnSpMk id="5" creationId="{14EAC6D4-DCD6-4BFD-B583-139C44784912}"/>
-          </ac:cxnSpMkLst>
-        </pc:cxnChg>
-        <pc:cxnChg chg="add mod">
-          <ac:chgData name="Julien Otis-Laperrière" userId="f155e897-dc35-4228-8a21-1627442ea9bf" providerId="ADAL" clId="{E9DF4F5E-E9CF-4228-8ACD-5373012E048E}" dt="2025-08-11T16:15:35.216" v="960"/>
-          <ac:cxnSpMkLst>
-            <pc:docMk/>
-            <pc:sldMk cId="3563616629" sldId="257"/>
-            <ac:cxnSpMk id="7" creationId="{1E8F7FB0-B608-C204-13BD-A5B072317C44}"/>
-          </ac:cxnSpMkLst>
-        </pc:cxnChg>
-      </pc:sldChg>
-      <pc:sldChg chg="addSp delSp modSp new mod">
-        <pc:chgData name="Julien Otis-Laperrière" userId="f155e897-dc35-4228-8a21-1627442ea9bf" providerId="ADAL" clId="{E9DF4F5E-E9CF-4228-8ACD-5373012E048E}" dt="2025-08-12T15:55:03.383" v="3351" actId="20577"/>
+      <pc:sldChg chg="modSp mod">
+        <pc:chgData name="Julien Otis-Laperrière" userId="f155e897-dc35-4228-8a21-1627442ea9bf" providerId="ADAL" clId="{62CFAC18-12DD-4069-AF2D-D3D5F30C1BC4}" dt="2026-04-23T00:12:17.517" v="117" actId="5736"/>
         <pc:sldMkLst>
           <pc:docMk/>
           <pc:sldMk cId="3245617924" sldId="258"/>
         </pc:sldMkLst>
-        <pc:spChg chg="add del">
-          <ac:chgData name="Julien Otis-Laperrière" userId="f155e897-dc35-4228-8a21-1627442ea9bf" providerId="ADAL" clId="{E9DF4F5E-E9CF-4228-8ACD-5373012E048E}" dt="2025-08-11T20:47:43.705" v="1003" actId="3680"/>
-          <ac:spMkLst>
-            <pc:docMk/>
-            <pc:sldMk cId="3245617924" sldId="258"/>
-            <ac:spMk id="3" creationId="{1CC69AD9-883A-D982-3284-9FED0E082F1A}"/>
-          </ac:spMkLst>
-        </pc:spChg>
-        <pc:spChg chg="add del mod">
-          <ac:chgData name="Julien Otis-Laperrière" userId="f155e897-dc35-4228-8a21-1627442ea9bf" providerId="ADAL" clId="{E9DF4F5E-E9CF-4228-8ACD-5373012E048E}" dt="2025-08-11T23:09:58.954" v="2494" actId="478"/>
-          <ac:spMkLst>
-            <pc:docMk/>
-            <pc:sldMk cId="3245617924" sldId="258"/>
-            <ac:spMk id="9" creationId="{255EBB3B-7F6B-FFBE-D64D-073AABE99A3E}"/>
-          </ac:spMkLst>
-        </pc:spChg>
-        <pc:graphicFrameChg chg="add mod">
-          <ac:chgData name="Julien Otis-Laperrière" userId="f155e897-dc35-4228-8a21-1627442ea9bf" providerId="ADAL" clId="{E9DF4F5E-E9CF-4228-8ACD-5373012E048E}" dt="2025-08-11T20:47:29.079" v="1000"/>
-          <ac:graphicFrameMkLst>
-            <pc:docMk/>
-            <pc:sldMk cId="3245617924" sldId="258"/>
-            <ac:graphicFrameMk id="4" creationId="{30466C8D-DBCC-F08D-3AE5-60627E50A9DB}"/>
-          </ac:graphicFrameMkLst>
-        </pc:graphicFrameChg>
-        <pc:graphicFrameChg chg="add del mod ord modGraphic">
-          <ac:chgData name="Julien Otis-Laperrière" userId="f155e897-dc35-4228-8a21-1627442ea9bf" providerId="ADAL" clId="{E9DF4F5E-E9CF-4228-8ACD-5373012E048E}" dt="2025-08-11T20:47:38.559" v="1002" actId="3680"/>
-          <ac:graphicFrameMkLst>
-            <pc:docMk/>
-            <pc:sldMk cId="3245617924" sldId="258"/>
-            <ac:graphicFrameMk id="5" creationId="{AAA350F2-DA61-D038-7713-E5DA47AAAC40}"/>
-          </ac:graphicFrameMkLst>
-        </pc:graphicFrameChg>
-        <pc:graphicFrameChg chg="add del mod ord modGraphic">
-          <ac:chgData name="Julien Otis-Laperrière" userId="f155e897-dc35-4228-8a21-1627442ea9bf" providerId="ADAL" clId="{E9DF4F5E-E9CF-4228-8ACD-5373012E048E}" dt="2025-08-11T23:09:56.734" v="2493" actId="478"/>
-          <ac:graphicFrameMkLst>
-            <pc:docMk/>
-            <pc:sldMk cId="3245617924" sldId="258"/>
-            <ac:graphicFrameMk id="6" creationId="{C9A8D629-22A9-D0CC-B09D-EE4D99687AC6}"/>
-          </ac:graphicFrameMkLst>
-        </pc:graphicFrameChg>
-        <pc:graphicFrameChg chg="add mod modGraphic">
-          <ac:chgData name="Julien Otis-Laperrière" userId="f155e897-dc35-4228-8a21-1627442ea9bf" providerId="ADAL" clId="{E9DF4F5E-E9CF-4228-8ACD-5373012E048E}" dt="2025-08-12T15:55:03.383" v="3351" actId="20577"/>
+        <pc:graphicFrameChg chg="mod modGraphic">
+          <ac:chgData name="Julien Otis-Laperrière" userId="f155e897-dc35-4228-8a21-1627442ea9bf" providerId="ADAL" clId="{62CFAC18-12DD-4069-AF2D-D3D5F30C1BC4}" dt="2026-04-23T00:12:17.517" v="117" actId="5736"/>
           <ac:graphicFrameMkLst>
             <pc:docMk/>
             <pc:sldMk cId="3245617924" sldId="258"/>
@@ -562,7 +300,7 @@
           <a:p>
             <a:fld id="{E3F4F018-BA6C-4119-8338-9A591E6E282A}" type="datetimeFigureOut">
               <a:rPr lang="en-CA" smtClean="0"/>
-              <a:t>2025-08-12</a:t>
+              <a:t>2026-04-22</a:t>
             </a:fld>
             <a:endParaRPr lang="en-CA"/>
           </a:p>
@@ -762,7 +500,7 @@
           <a:p>
             <a:fld id="{E3F4F018-BA6C-4119-8338-9A591E6E282A}" type="datetimeFigureOut">
               <a:rPr lang="en-CA" smtClean="0"/>
-              <a:t>2025-08-12</a:t>
+              <a:t>2026-04-22</a:t>
             </a:fld>
             <a:endParaRPr lang="en-CA"/>
           </a:p>
@@ -972,7 +710,7 @@
           <a:p>
             <a:fld id="{E3F4F018-BA6C-4119-8338-9A591E6E282A}" type="datetimeFigureOut">
               <a:rPr lang="en-CA" smtClean="0"/>
-              <a:t>2025-08-12</a:t>
+              <a:t>2026-04-22</a:t>
             </a:fld>
             <a:endParaRPr lang="en-CA"/>
           </a:p>
@@ -1172,7 +910,7 @@
           <a:p>
             <a:fld id="{E3F4F018-BA6C-4119-8338-9A591E6E282A}" type="datetimeFigureOut">
               <a:rPr lang="en-CA" smtClean="0"/>
-              <a:t>2025-08-12</a:t>
+              <a:t>2026-04-22</a:t>
             </a:fld>
             <a:endParaRPr lang="en-CA"/>
           </a:p>
@@ -1448,7 +1186,7 @@
           <a:p>
             <a:fld id="{E3F4F018-BA6C-4119-8338-9A591E6E282A}" type="datetimeFigureOut">
               <a:rPr lang="en-CA" smtClean="0"/>
-              <a:t>2025-08-12</a:t>
+              <a:t>2026-04-22</a:t>
             </a:fld>
             <a:endParaRPr lang="en-CA"/>
           </a:p>
@@ -1716,7 +1454,7 @@
           <a:p>
             <a:fld id="{E3F4F018-BA6C-4119-8338-9A591E6E282A}" type="datetimeFigureOut">
               <a:rPr lang="en-CA" smtClean="0"/>
-              <a:t>2025-08-12</a:t>
+              <a:t>2026-04-22</a:t>
             </a:fld>
             <a:endParaRPr lang="en-CA"/>
           </a:p>
@@ -2131,7 +1869,7 @@
           <a:p>
             <a:fld id="{E3F4F018-BA6C-4119-8338-9A591E6E282A}" type="datetimeFigureOut">
               <a:rPr lang="en-CA" smtClean="0"/>
-              <a:t>2025-08-12</a:t>
+              <a:t>2026-04-22</a:t>
             </a:fld>
             <a:endParaRPr lang="en-CA"/>
           </a:p>
@@ -2273,7 +2011,7 @@
           <a:p>
             <a:fld id="{E3F4F018-BA6C-4119-8338-9A591E6E282A}" type="datetimeFigureOut">
               <a:rPr lang="en-CA" smtClean="0"/>
-              <a:t>2025-08-12</a:t>
+              <a:t>2026-04-22</a:t>
             </a:fld>
             <a:endParaRPr lang="en-CA"/>
           </a:p>
@@ -2386,7 +2124,7 @@
           <a:p>
             <a:fld id="{E3F4F018-BA6C-4119-8338-9A591E6E282A}" type="datetimeFigureOut">
               <a:rPr lang="en-CA" smtClean="0"/>
-              <a:t>2025-08-12</a:t>
+              <a:t>2026-04-22</a:t>
             </a:fld>
             <a:endParaRPr lang="en-CA"/>
           </a:p>
@@ -2699,7 +2437,7 @@
           <a:p>
             <a:fld id="{E3F4F018-BA6C-4119-8338-9A591E6E282A}" type="datetimeFigureOut">
               <a:rPr lang="en-CA" smtClean="0"/>
-              <a:t>2025-08-12</a:t>
+              <a:t>2026-04-22</a:t>
             </a:fld>
             <a:endParaRPr lang="en-CA"/>
           </a:p>
@@ -2988,7 +2726,7 @@
           <a:p>
             <a:fld id="{E3F4F018-BA6C-4119-8338-9A591E6E282A}" type="datetimeFigureOut">
               <a:rPr lang="en-CA" smtClean="0"/>
-              <a:t>2025-08-12</a:t>
+              <a:t>2026-04-22</a:t>
             </a:fld>
             <a:endParaRPr lang="en-CA"/>
           </a:p>
@@ -3231,7 +2969,7 @@
           <a:p>
             <a:fld id="{E3F4F018-BA6C-4119-8338-9A591E6E282A}" type="datetimeFigureOut">
               <a:rPr lang="en-CA" smtClean="0"/>
-              <a:t>2025-08-12</a:t>
+              <a:t>2026-04-22</a:t>
             </a:fld>
             <a:endParaRPr lang="en-CA"/>
           </a:p>
@@ -5152,7 +4890,7 @@
           <p:nvPr>
             <p:extLst>
               <p:ext uri="{D42A27DB-BD31-4B8C-83A1-F6EECF244321}">
-                <p14:modId xmlns:p14="http://schemas.microsoft.com/office/powerpoint/2010/main" val="988948380"/>
+                <p14:modId xmlns:p14="http://schemas.microsoft.com/office/powerpoint/2010/main" val="3829128965"/>
               </p:ext>
             </p:extLst>
           </p:nvPr>
@@ -5778,7 +5516,7 @@
                     <a:p>
                       <a:r>
                         <a:rPr lang="en-CA" sz="1400" b="0" dirty="0"/>
-                        <a:t>Substation battery dispatching when load &gt; power line in after soaking far-off supply.</a:t>
+                        <a:t>Substation battery fed by far-off supply dispatching when load &gt; power line capacity.</a:t>
                       </a:r>
                       <a:endParaRPr lang="en-CA" sz="1400" b="1" dirty="0"/>
                     </a:p>

</xml_diff>